<commit_message>
Add Knowledge Check section to deck; add competency scoring grid
- Onboarding deck: add a three-round Knowledge Check section (Safety &
  Scope, Patient Journey & Deadlines, Screening & Documentation) before
  the closing slide, with trainer answers in the speaker notes; deck is
  now 23 slides
- Add "CharmEd Minds Competency Scoring Grid.xlsx": per-question Score
  Sheet (answer key as a gradable grid with SUMIFS auto-tally, an 80% +
  Part-B-100% pass gate, and conditional formatting), a Class Roster for
  the whole team, and an Instructions tab
- Sync generators into tools/ (build_gradebook.py added) and update
  README indexes

Note: formulas compute on open; cached values are not pre-populated
because LibreOffice is unavailable in this environment.

Co-Authored-By: Claude Opus 4.8 <noreply@anthropic.com>
Claude-Session: https://claude.ai/code/session_01XYQMpLHonr9Q1GnBUpeh8D
</commit_message>
<xml_diff>
--- a/CharmEd Minds Onboarding Deck.pptx
+++ b/CharmEd Minds Onboarding Deck.pptx
@@ -25,9 +25,12 @@
     <p:sldId id="273" r:id="rId19"/>
     <p:sldId id="274" r:id="rId20"/>
     <p:sldId id="275" r:id="rId21"/>
+    <p:sldId id="276" r:id="rId22"/>
+    <p:sldId id="277" r:id="rId23"/>
+    <p:sldId id="278" r:id="rId24"/>
   </p:sldIdLst>
   <p:notesMasterIdLst>
-    <p:notesMasterId r:id="rId22"/>
+    <p:notesMasterId r:id="rId25"/>
   </p:notesMasterIdLst>
   <p:sldSz cx="12191695" cy="6858000"/>
   <p:notesSz cx="6858000" cy="12191695"/>
@@ -1577,7 +1580,7 @@
           <a:p>
             <a:r>
               <a:rPr lang="en-US" dirty="0"/>
-              <a:t>Close on the promise. Point staff to the full guide and their role competency checklist.</a:t>
+              <a:t>KNOWLEDGE CHECK — Safety &amp; Scope. Answers: (1) These are screening tools; the Provider reviews and discusses — do NOT diagnose; put it on the review list. (2) The Provider only. (3) Tell the APD immediately; APD routes to Provider same day. (4) MAY NOT: diagnose, interpret clinically, adjust meds/order labs, decide medical necessity.</a:t>
             </a:r>
             <a:endParaRPr lang="en-US" dirty="0"/>
           </a:p>
@@ -1601,6 +1604,270 @@
             <a:fld id="{F7021451-1387-4CA6-816F-3879F97B5CBC}" type="slidenum">
               <a:rPr lang="en-US"/>
               <a:t>20</a:t>
+            </a:fld>
+            <a:endParaRPr lang="en-US"/>
+          </a:p>
+        </p:txBody>
+      </p:sp>
+    </p:spTree>
+    <p:extLst>
+      <p:ext uri="{BB962C8B-B14F-4D97-AF65-F5344CB8AC3E}">
+        <p14:creationId xmlns:p14="http://schemas.microsoft.com/office/powerpoint/2010/main" val="1024086991"/>
+      </p:ext>
+    </p:extLst>
+  </p:cSld>
+  <p:clrMapOvr>
+    <a:masterClrMapping/>
+  </p:clrMapOvr>
+</p:notes>
+</file>
+
+<file path=ppt/notesSlides/notesSlide21.xml><?xml version="1.0" encoding="utf-8"?>
+<p:notes xmlns:a="http://schemas.openxmlformats.org/drawingml/2006/main" xmlns:r="http://schemas.openxmlformats.org/officeDocument/2006/relationships" xmlns:p="http://schemas.openxmlformats.org/presentationml/2006/main">
+  <p:cSld>
+    <p:spTree>
+      <p:nvGrpSpPr>
+        <p:cNvPr id="1" name=""/>
+        <p:cNvGrpSpPr/>
+        <p:nvPr/>
+      </p:nvGrpSpPr>
+      <p:grpSpPr>
+        <a:xfrm>
+          <a:off x="0" y="0"/>
+          <a:ext cx="0" cy="0"/>
+          <a:chOff x="0" y="0"/>
+          <a:chExt cx="0" cy="0"/>
+        </a:xfrm>
+      </p:grpSpPr>
+      <p:sp>
+        <p:nvSpPr>
+          <p:cNvPr id="2" name="Slide Image Placeholder 1"/>
+          <p:cNvSpPr>
+            <a:spLocks noGrp="1" noRot="1" noChangeAspect="1"/>
+          </p:cNvSpPr>
+          <p:nvPr>
+            <p:ph type="sldImg"/>
+          </p:nvPr>
+        </p:nvSpPr>
+        <p:spPr/>
+      </p:sp>
+      <p:sp>
+        <p:nvSpPr>
+          <p:cNvPr id="3" name="Notes Placeholder 2"/>
+          <p:cNvSpPr>
+            <a:spLocks noGrp="1"/>
+          </p:cNvSpPr>
+          <p:nvPr>
+            <p:ph type="body" idx="1"/>
+          </p:nvPr>
+        </p:nvSpPr>
+        <p:spPr/>
+        <p:txBody>
+          <a:bodyPr/>
+          <a:lstStyle/>
+          <a:p>
+            <a:r>
+              <a:rPr lang="en-US" dirty="0"/>
+              <a:t>KNOWLEDGE CHECK — Journey &amp; Deadlines. Answers: (1) 24 hours. (2) 48 hours. (3) Same day. (4) The APD reviews it first, before the Provider.</a:t>
+            </a:r>
+            <a:endParaRPr lang="en-US" dirty="0"/>
+          </a:p>
+        </p:txBody>
+      </p:sp>
+      <p:sp>
+        <p:nvSpPr>
+          <p:cNvPr id="4" name="Slide Number Placeholder 3"/>
+          <p:cNvSpPr>
+            <a:spLocks noGrp="1"/>
+          </p:cNvSpPr>
+          <p:nvPr>
+            <p:ph type="sldNum" sz="quarter" idx="10"/>
+          </p:nvPr>
+        </p:nvSpPr>
+        <p:spPr/>
+        <p:txBody>
+          <a:bodyPr/>
+          <a:lstStyle/>
+          <a:p>
+            <a:fld id="{F7021451-1387-4CA6-816F-3879F97B5CBC}" type="slidenum">
+              <a:rPr lang="en-US"/>
+              <a:t>21</a:t>
+            </a:fld>
+            <a:endParaRPr lang="en-US"/>
+          </a:p>
+        </p:txBody>
+      </p:sp>
+    </p:spTree>
+    <p:extLst>
+      <p:ext uri="{BB962C8B-B14F-4D97-AF65-F5344CB8AC3E}">
+        <p14:creationId xmlns:p14="http://schemas.microsoft.com/office/powerpoint/2010/main" val="1024086991"/>
+      </p:ext>
+    </p:extLst>
+  </p:cSld>
+  <p:clrMapOvr>
+    <a:masterClrMapping/>
+  </p:clrMapOvr>
+</p:notes>
+</file>
+
+<file path=ppt/notesSlides/notesSlide22.xml><?xml version="1.0" encoding="utf-8"?>
+<p:notes xmlns:a="http://schemas.openxmlformats.org/drawingml/2006/main" xmlns:r="http://schemas.openxmlformats.org/officeDocument/2006/relationships" xmlns:p="http://schemas.openxmlformats.org/presentationml/2006/main">
+  <p:cSld>
+    <p:spTree>
+      <p:nvGrpSpPr>
+        <p:cNvPr id="1" name=""/>
+        <p:cNvGrpSpPr/>
+        <p:nvPr/>
+      </p:nvGrpSpPr>
+      <p:grpSpPr>
+        <a:xfrm>
+          <a:off x="0" y="0"/>
+          <a:ext cx="0" cy="0"/>
+          <a:chOff x="0" y="0"/>
+          <a:chExt cx="0" cy="0"/>
+        </a:xfrm>
+      </p:grpSpPr>
+      <p:sp>
+        <p:nvSpPr>
+          <p:cNvPr id="2" name="Slide Image Placeholder 1"/>
+          <p:cNvSpPr>
+            <a:spLocks noGrp="1" noRot="1" noChangeAspect="1"/>
+          </p:cNvSpPr>
+          <p:nvPr>
+            <p:ph type="sldImg"/>
+          </p:nvPr>
+        </p:nvSpPr>
+        <p:spPr/>
+      </p:sp>
+      <p:sp>
+        <p:nvSpPr>
+          <p:cNvPr id="3" name="Notes Placeholder 2"/>
+          <p:cNvSpPr>
+            <a:spLocks noGrp="1"/>
+          </p:cNvSpPr>
+          <p:nvPr>
+            <p:ph type="body" idx="1"/>
+          </p:nvPr>
+        </p:nvSpPr>
+        <p:spPr/>
+        <p:txBody>
+          <a:bodyPr/>
+          <a:lstStyle/>
+          <a:p>
+            <a:r>
+              <a:rPr lang="en-US" dirty="0"/>
+              <a:t>KNOWLEDGE CHECK — Screening &amp; Documentation. Answers: (1) CogniFit and Creyos. (2) ADHD tool + autism-trait tool + executive-function tool + sensory profile. (3) ICD-10, deficits, interventions, functional response, homework. (4) Replace a formal diagnostic evaluation.</a:t>
+            </a:r>
+            <a:endParaRPr lang="en-US" dirty="0"/>
+          </a:p>
+        </p:txBody>
+      </p:sp>
+      <p:sp>
+        <p:nvSpPr>
+          <p:cNvPr id="4" name="Slide Number Placeholder 3"/>
+          <p:cNvSpPr>
+            <a:spLocks noGrp="1"/>
+          </p:cNvSpPr>
+          <p:nvPr>
+            <p:ph type="sldNum" sz="quarter" idx="10"/>
+          </p:nvPr>
+        </p:nvSpPr>
+        <p:spPr/>
+        <p:txBody>
+          <a:bodyPr/>
+          <a:lstStyle/>
+          <a:p>
+            <a:fld id="{F7021451-1387-4CA6-816F-3879F97B5CBC}" type="slidenum">
+              <a:rPr lang="en-US"/>
+              <a:t>22</a:t>
+            </a:fld>
+            <a:endParaRPr lang="en-US"/>
+          </a:p>
+        </p:txBody>
+      </p:sp>
+    </p:spTree>
+    <p:extLst>
+      <p:ext uri="{BB962C8B-B14F-4D97-AF65-F5344CB8AC3E}">
+        <p14:creationId xmlns:p14="http://schemas.microsoft.com/office/powerpoint/2010/main" val="1024086991"/>
+      </p:ext>
+    </p:extLst>
+  </p:cSld>
+  <p:clrMapOvr>
+    <a:masterClrMapping/>
+  </p:clrMapOvr>
+</p:notes>
+</file>
+
+<file path=ppt/notesSlides/notesSlide23.xml><?xml version="1.0" encoding="utf-8"?>
+<p:notes xmlns:a="http://schemas.openxmlformats.org/drawingml/2006/main" xmlns:r="http://schemas.openxmlformats.org/officeDocument/2006/relationships" xmlns:p="http://schemas.openxmlformats.org/presentationml/2006/main">
+  <p:cSld>
+    <p:spTree>
+      <p:nvGrpSpPr>
+        <p:cNvPr id="1" name=""/>
+        <p:cNvGrpSpPr/>
+        <p:nvPr/>
+      </p:nvGrpSpPr>
+      <p:grpSpPr>
+        <a:xfrm>
+          <a:off x="0" y="0"/>
+          <a:ext cx="0" cy="0"/>
+          <a:chOff x="0" y="0"/>
+          <a:chExt cx="0" cy="0"/>
+        </a:xfrm>
+      </p:grpSpPr>
+      <p:sp>
+        <p:nvSpPr>
+          <p:cNvPr id="2" name="Slide Image Placeholder 1"/>
+          <p:cNvSpPr>
+            <a:spLocks noGrp="1" noRot="1" noChangeAspect="1"/>
+          </p:cNvSpPr>
+          <p:nvPr>
+            <p:ph type="sldImg"/>
+          </p:nvPr>
+        </p:nvSpPr>
+        <p:spPr/>
+      </p:sp>
+      <p:sp>
+        <p:nvSpPr>
+          <p:cNvPr id="3" name="Notes Placeholder 2"/>
+          <p:cNvSpPr>
+            <a:spLocks noGrp="1"/>
+          </p:cNvSpPr>
+          <p:nvPr>
+            <p:ph type="body" idx="1"/>
+          </p:nvPr>
+        </p:nvSpPr>
+        <p:spPr/>
+        <p:txBody>
+          <a:bodyPr/>
+          <a:lstStyle/>
+          <a:p>
+            <a:r>
+              <a:rPr lang="en-US" dirty="0"/>
+              <a:t>Close on the promise. Point staff to the full guide, the written competency assessment + sign-off, and their role competency checklist.</a:t>
+            </a:r>
+            <a:endParaRPr lang="en-US" dirty="0"/>
+          </a:p>
+        </p:txBody>
+      </p:sp>
+      <p:sp>
+        <p:nvSpPr>
+          <p:cNvPr id="4" name="Slide Number Placeholder 3"/>
+          <p:cNvSpPr>
+            <a:spLocks noGrp="1"/>
+          </p:cNvSpPr>
+          <p:nvPr>
+            <p:ph type="sldNum" sz="quarter" idx="10"/>
+          </p:nvPr>
+        </p:nvSpPr>
+        <p:spPr/>
+        <p:txBody>
+          <a:bodyPr/>
+          <a:lstStyle/>
+          <a:p>
+            <a:fld id="{F7021451-1387-4CA6-816F-3879F97B5CBC}" type="slidenum">
+              <a:rPr lang="en-US"/>
+              <a:t>23</a:t>
             </a:fld>
             <a:endParaRPr lang="en-US"/>
           </a:p>
@@ -14487,6 +14754,2259 @@
       </p:grpSpPr>
       <p:sp>
         <p:nvSpPr>
+          <p:cNvPr id="2" name="Text 0"/>
+          <p:cNvSpPr/>
+          <p:nvPr/>
+        </p:nvSpPr>
+        <p:spPr>
+          <a:xfrm>
+            <a:off x="548640" y="411480"/>
+            <a:ext cx="10972800" cy="274320"/>
+          </a:xfrm>
+          <a:prstGeom prst="rect">
+            <a:avLst/>
+          </a:prstGeom>
+          <a:noFill/>
+          <a:ln/>
+        </p:spPr>
+        <p:txBody>
+          <a:bodyPr wrap="square" rtlCol="0" anchor="ctr"/>
+          <a:lstStyle/>
+          <a:p>
+            <a:pPr indent="0" marL="0">
+              <a:buNone/>
+            </a:pPr>
+            <a:r>
+              <a:rPr lang="en-US" sz="1200" b="1" spc="200" kern="0" dirty="0">
+                <a:solidFill>
+                  <a:srgbClr val="02C39A"/>
+                </a:solidFill>
+                <a:latin typeface="Calibri" pitchFamily="34" charset="0"/>
+                <a:ea typeface="Calibri" pitchFamily="34" charset="-122"/>
+                <a:cs typeface="Calibri" pitchFamily="34" charset="-120"/>
+              </a:rPr>
+              <a:t>KNOWLEDGE CHECK · ROUND 1</a:t>
+            </a:r>
+            <a:endParaRPr lang="en-US" sz="1200" dirty="0"/>
+          </a:p>
+        </p:txBody>
+      </p:sp>
+      <p:sp>
+        <p:nvSpPr>
+          <p:cNvPr id="3" name="Text 1"/>
+          <p:cNvSpPr/>
+          <p:nvPr/>
+        </p:nvSpPr>
+        <p:spPr>
+          <a:xfrm>
+            <a:off x="548640" y="658368"/>
+            <a:ext cx="11064240" cy="731520"/>
+          </a:xfrm>
+          <a:prstGeom prst="rect">
+            <a:avLst/>
+          </a:prstGeom>
+          <a:noFill/>
+          <a:ln/>
+        </p:spPr>
+        <p:txBody>
+          <a:bodyPr wrap="square" rtlCol="0" anchor="ctr"/>
+          <a:lstStyle/>
+          <a:p>
+            <a:pPr indent="0" marL="0">
+              <a:buNone/>
+            </a:pPr>
+            <a:r>
+              <a:rPr lang="en-US" sz="3000" b="1" dirty="0">
+                <a:solidFill>
+                  <a:srgbClr val="FFFFFF"/>
+                </a:solidFill>
+                <a:latin typeface="Cambria" pitchFamily="34" charset="0"/>
+                <a:ea typeface="Cambria" pitchFamily="34" charset="-122"/>
+                <a:cs typeface="Cambria" pitchFamily="34" charset="-120"/>
+              </a:rPr>
+              <a:t>Safety &amp; Scope</a:t>
+            </a:r>
+            <a:endParaRPr lang="en-US" sz="3000" dirty="0"/>
+          </a:p>
+        </p:txBody>
+      </p:sp>
+      <p:sp>
+        <p:nvSpPr>
+          <p:cNvPr id="4" name="Shape 2"/>
+          <p:cNvSpPr/>
+          <p:nvPr/>
+        </p:nvSpPr>
+        <p:spPr>
+          <a:xfrm>
+            <a:off x="548640" y="1691640"/>
+            <a:ext cx="5440680" cy="1920240"/>
+          </a:xfrm>
+          <a:prstGeom prst="roundRect">
+            <a:avLst>
+              <a:gd name="adj" fmla="val 4762"/>
+            </a:avLst>
+          </a:prstGeom>
+          <a:solidFill>
+            <a:srgbClr val="2B3A7A"/>
+          </a:solidFill>
+          <a:ln/>
+        </p:spPr>
+      </p:sp>
+      <p:sp>
+        <p:nvSpPr>
+          <p:cNvPr id="5" name="Shape 3"/>
+          <p:cNvSpPr/>
+          <p:nvPr/>
+        </p:nvSpPr>
+        <p:spPr>
+          <a:xfrm>
+            <a:off x="804672" y="1947672"/>
+            <a:ext cx="548640" cy="548640"/>
+          </a:xfrm>
+          <a:prstGeom prst="ellipse">
+            <a:avLst/>
+          </a:prstGeom>
+          <a:solidFill>
+            <a:srgbClr val="02C39A"/>
+          </a:solidFill>
+          <a:ln/>
+        </p:spPr>
+      </p:sp>
+      <p:sp>
+        <p:nvSpPr>
+          <p:cNvPr id="6" name="Text 4"/>
+          <p:cNvSpPr/>
+          <p:nvPr/>
+        </p:nvSpPr>
+        <p:spPr>
+          <a:xfrm>
+            <a:off x="804672" y="1947672"/>
+            <a:ext cx="548640" cy="548640"/>
+          </a:xfrm>
+          <a:prstGeom prst="rect">
+            <a:avLst/>
+          </a:prstGeom>
+          <a:noFill/>
+          <a:ln/>
+        </p:spPr>
+        <p:txBody>
+          <a:bodyPr wrap="square" rtlCol="0" anchor="ctr"/>
+          <a:lstStyle/>
+          <a:p>
+            <a:pPr algn="ctr" indent="0" marL="0">
+              <a:buNone/>
+            </a:pPr>
+            <a:r>
+              <a:rPr lang="en-US" sz="1500" b="1" dirty="0">
+                <a:solidFill>
+                  <a:srgbClr val="1E2761"/>
+                </a:solidFill>
+                <a:latin typeface="Calibri" pitchFamily="34" charset="0"/>
+                <a:ea typeface="Calibri" pitchFamily="34" charset="-122"/>
+                <a:cs typeface="Calibri" pitchFamily="34" charset="-120"/>
+              </a:rPr>
+              <a:t>Q1</a:t>
+            </a:r>
+            <a:endParaRPr lang="en-US" sz="1500" dirty="0"/>
+          </a:p>
+        </p:txBody>
+      </p:sp>
+      <p:sp>
+        <p:nvSpPr>
+          <p:cNvPr id="7" name="Text 5"/>
+          <p:cNvSpPr/>
+          <p:nvPr/>
+        </p:nvSpPr>
+        <p:spPr>
+          <a:xfrm>
+            <a:off x="1508760" y="1947672"/>
+            <a:ext cx="4206240" cy="1417320"/>
+          </a:xfrm>
+          <a:prstGeom prst="rect">
+            <a:avLst/>
+          </a:prstGeom>
+          <a:noFill/>
+          <a:ln/>
+        </p:spPr>
+        <p:txBody>
+          <a:bodyPr wrap="square" rtlCol="0" anchor="ctr"/>
+          <a:lstStyle/>
+          <a:p>
+            <a:pPr indent="0" marL="0">
+              <a:lnSpc>
+                <a:spcPct val="110000"/>
+              </a:lnSpc>
+              <a:buNone/>
+            </a:pPr>
+            <a:r>
+              <a:rPr lang="en-US" sz="1500" dirty="0">
+                <a:solidFill>
+                  <a:srgbClr val="FFFFFF"/>
+                </a:solidFill>
+                <a:latin typeface="Calibri" pitchFamily="34" charset="0"/>
+                <a:ea typeface="Calibri" pitchFamily="34" charset="-122"/>
+                <a:cs typeface="Calibri" pitchFamily="34" charset="-120"/>
+              </a:rPr>
+              <a:t>A patient asks, "Do I have ADHD?" What do you say and do?</a:t>
+            </a:r>
+            <a:endParaRPr lang="en-US" sz="1500" dirty="0"/>
+          </a:p>
+        </p:txBody>
+      </p:sp>
+      <p:sp>
+        <p:nvSpPr>
+          <p:cNvPr id="8" name="Shape 6"/>
+          <p:cNvSpPr/>
+          <p:nvPr/>
+        </p:nvSpPr>
+        <p:spPr>
+          <a:xfrm>
+            <a:off x="6172200" y="1691640"/>
+            <a:ext cx="5440680" cy="1920240"/>
+          </a:xfrm>
+          <a:prstGeom prst="roundRect">
+            <a:avLst>
+              <a:gd name="adj" fmla="val 4762"/>
+            </a:avLst>
+          </a:prstGeom>
+          <a:solidFill>
+            <a:srgbClr val="2B3A7A"/>
+          </a:solidFill>
+          <a:ln/>
+        </p:spPr>
+      </p:sp>
+      <p:sp>
+        <p:nvSpPr>
+          <p:cNvPr id="9" name="Shape 7"/>
+          <p:cNvSpPr/>
+          <p:nvPr/>
+        </p:nvSpPr>
+        <p:spPr>
+          <a:xfrm>
+            <a:off x="6428232" y="1947672"/>
+            <a:ext cx="548640" cy="548640"/>
+          </a:xfrm>
+          <a:prstGeom prst="ellipse">
+            <a:avLst/>
+          </a:prstGeom>
+          <a:solidFill>
+            <a:srgbClr val="02C39A"/>
+          </a:solidFill>
+          <a:ln/>
+        </p:spPr>
+      </p:sp>
+      <p:sp>
+        <p:nvSpPr>
+          <p:cNvPr id="10" name="Text 8"/>
+          <p:cNvSpPr/>
+          <p:nvPr/>
+        </p:nvSpPr>
+        <p:spPr>
+          <a:xfrm>
+            <a:off x="6428232" y="1947672"/>
+            <a:ext cx="548640" cy="548640"/>
+          </a:xfrm>
+          <a:prstGeom prst="rect">
+            <a:avLst/>
+          </a:prstGeom>
+          <a:noFill/>
+          <a:ln/>
+        </p:spPr>
+        <p:txBody>
+          <a:bodyPr wrap="square" rtlCol="0" anchor="ctr"/>
+          <a:lstStyle/>
+          <a:p>
+            <a:pPr algn="ctr" indent="0" marL="0">
+              <a:buNone/>
+            </a:pPr>
+            <a:r>
+              <a:rPr lang="en-US" sz="1500" b="1" dirty="0">
+                <a:solidFill>
+                  <a:srgbClr val="1E2761"/>
+                </a:solidFill>
+                <a:latin typeface="Calibri" pitchFamily="34" charset="0"/>
+                <a:ea typeface="Calibri" pitchFamily="34" charset="-122"/>
+                <a:cs typeface="Calibri" pitchFamily="34" charset="-120"/>
+              </a:rPr>
+              <a:t>Q2</a:t>
+            </a:r>
+            <a:endParaRPr lang="en-US" sz="1500" dirty="0"/>
+          </a:p>
+        </p:txBody>
+      </p:sp>
+      <p:sp>
+        <p:nvSpPr>
+          <p:cNvPr id="11" name="Text 9"/>
+          <p:cNvSpPr/>
+          <p:nvPr/>
+        </p:nvSpPr>
+        <p:spPr>
+          <a:xfrm>
+            <a:off x="7132320" y="1947672"/>
+            <a:ext cx="4206240" cy="1417320"/>
+          </a:xfrm>
+          <a:prstGeom prst="rect">
+            <a:avLst/>
+          </a:prstGeom>
+          <a:noFill/>
+          <a:ln/>
+        </p:spPr>
+        <p:txBody>
+          <a:bodyPr wrap="square" rtlCol="0" anchor="ctr"/>
+          <a:lstStyle/>
+          <a:p>
+            <a:pPr indent="0" marL="0">
+              <a:lnSpc>
+                <a:spcPct val="110000"/>
+              </a:lnSpc>
+              <a:buNone/>
+            </a:pPr>
+            <a:r>
+              <a:rPr lang="en-US" sz="1500" dirty="0">
+                <a:solidFill>
+                  <a:srgbClr val="FFFFFF"/>
+                </a:solidFill>
+                <a:latin typeface="Calibri" pitchFamily="34" charset="0"/>
+                <a:ea typeface="Calibri" pitchFamily="34" charset="-122"/>
+                <a:cs typeface="Calibri" pitchFamily="34" charset="-120"/>
+              </a:rPr>
+              <a:t>Who may order and interpret labs?</a:t>
+            </a:r>
+            <a:endParaRPr lang="en-US" sz="1500" dirty="0"/>
+          </a:p>
+        </p:txBody>
+      </p:sp>
+      <p:sp>
+        <p:nvSpPr>
+          <p:cNvPr id="12" name="Shape 10"/>
+          <p:cNvSpPr/>
+          <p:nvPr/>
+        </p:nvSpPr>
+        <p:spPr>
+          <a:xfrm>
+            <a:off x="548640" y="3840480"/>
+            <a:ext cx="5440680" cy="1920240"/>
+          </a:xfrm>
+          <a:prstGeom prst="roundRect">
+            <a:avLst>
+              <a:gd name="adj" fmla="val 4762"/>
+            </a:avLst>
+          </a:prstGeom>
+          <a:solidFill>
+            <a:srgbClr val="2B3A7A"/>
+          </a:solidFill>
+          <a:ln/>
+        </p:spPr>
+      </p:sp>
+      <p:sp>
+        <p:nvSpPr>
+          <p:cNvPr id="13" name="Shape 11"/>
+          <p:cNvSpPr/>
+          <p:nvPr/>
+        </p:nvSpPr>
+        <p:spPr>
+          <a:xfrm>
+            <a:off x="804672" y="4096512"/>
+            <a:ext cx="548640" cy="548640"/>
+          </a:xfrm>
+          <a:prstGeom prst="ellipse">
+            <a:avLst/>
+          </a:prstGeom>
+          <a:solidFill>
+            <a:srgbClr val="02C39A"/>
+          </a:solidFill>
+          <a:ln/>
+        </p:spPr>
+      </p:sp>
+      <p:sp>
+        <p:nvSpPr>
+          <p:cNvPr id="14" name="Text 12"/>
+          <p:cNvSpPr/>
+          <p:nvPr/>
+        </p:nvSpPr>
+        <p:spPr>
+          <a:xfrm>
+            <a:off x="804672" y="4096512"/>
+            <a:ext cx="548640" cy="548640"/>
+          </a:xfrm>
+          <a:prstGeom prst="rect">
+            <a:avLst/>
+          </a:prstGeom>
+          <a:noFill/>
+          <a:ln/>
+        </p:spPr>
+        <p:txBody>
+          <a:bodyPr wrap="square" rtlCol="0" anchor="ctr"/>
+          <a:lstStyle/>
+          <a:p>
+            <a:pPr algn="ctr" indent="0" marL="0">
+              <a:buNone/>
+            </a:pPr>
+            <a:r>
+              <a:rPr lang="en-US" sz="1500" b="1" dirty="0">
+                <a:solidFill>
+                  <a:srgbClr val="1E2761"/>
+                </a:solidFill>
+                <a:latin typeface="Calibri" pitchFamily="34" charset="0"/>
+                <a:ea typeface="Calibri" pitchFamily="34" charset="-122"/>
+                <a:cs typeface="Calibri" pitchFamily="34" charset="-120"/>
+              </a:rPr>
+              <a:t>Q3</a:t>
+            </a:r>
+            <a:endParaRPr lang="en-US" sz="1500" dirty="0"/>
+          </a:p>
+        </p:txBody>
+      </p:sp>
+      <p:sp>
+        <p:nvSpPr>
+          <p:cNvPr id="15" name="Text 13"/>
+          <p:cNvSpPr/>
+          <p:nvPr/>
+        </p:nvSpPr>
+        <p:spPr>
+          <a:xfrm>
+            <a:off x="1508760" y="4096512"/>
+            <a:ext cx="4206240" cy="1417320"/>
+          </a:xfrm>
+          <a:prstGeom prst="rect">
+            <a:avLst/>
+          </a:prstGeom>
+          <a:noFill/>
+          <a:ln/>
+        </p:spPr>
+        <p:txBody>
+          <a:bodyPr wrap="square" rtlCol="0" anchor="ctr"/>
+          <a:lstStyle/>
+          <a:p>
+            <a:pPr indent="0" marL="0">
+              <a:lnSpc>
+                <a:spcPct val="110000"/>
+              </a:lnSpc>
+              <a:buNone/>
+            </a:pPr>
+            <a:r>
+              <a:rPr lang="en-US" sz="1500" dirty="0">
+                <a:solidFill>
+                  <a:srgbClr val="FFFFFF"/>
+                </a:solidFill>
+                <a:latin typeface="Calibri" pitchFamily="34" charset="0"/>
+                <a:ea typeface="Calibri" pitchFamily="34" charset="-122"/>
+                <a:cs typeface="Calibri" pitchFamily="34" charset="-120"/>
+              </a:rPr>
+              <a:t>You notice a red flag (sudden cognitive decline). What is your next step?</a:t>
+            </a:r>
+            <a:endParaRPr lang="en-US" sz="1500" dirty="0"/>
+          </a:p>
+        </p:txBody>
+      </p:sp>
+      <p:sp>
+        <p:nvSpPr>
+          <p:cNvPr id="16" name="Shape 14"/>
+          <p:cNvSpPr/>
+          <p:nvPr/>
+        </p:nvSpPr>
+        <p:spPr>
+          <a:xfrm>
+            <a:off x="6172200" y="3840480"/>
+            <a:ext cx="5440680" cy="1920240"/>
+          </a:xfrm>
+          <a:prstGeom prst="roundRect">
+            <a:avLst>
+              <a:gd name="adj" fmla="val 4762"/>
+            </a:avLst>
+          </a:prstGeom>
+          <a:solidFill>
+            <a:srgbClr val="2B3A7A"/>
+          </a:solidFill>
+          <a:ln/>
+        </p:spPr>
+      </p:sp>
+      <p:sp>
+        <p:nvSpPr>
+          <p:cNvPr id="17" name="Shape 15"/>
+          <p:cNvSpPr/>
+          <p:nvPr/>
+        </p:nvSpPr>
+        <p:spPr>
+          <a:xfrm>
+            <a:off x="6428232" y="4096512"/>
+            <a:ext cx="548640" cy="548640"/>
+          </a:xfrm>
+          <a:prstGeom prst="ellipse">
+            <a:avLst/>
+          </a:prstGeom>
+          <a:solidFill>
+            <a:srgbClr val="02C39A"/>
+          </a:solidFill>
+          <a:ln/>
+        </p:spPr>
+      </p:sp>
+      <p:sp>
+        <p:nvSpPr>
+          <p:cNvPr id="18" name="Text 16"/>
+          <p:cNvSpPr/>
+          <p:nvPr/>
+        </p:nvSpPr>
+        <p:spPr>
+          <a:xfrm>
+            <a:off x="6428232" y="4096512"/>
+            <a:ext cx="548640" cy="548640"/>
+          </a:xfrm>
+          <a:prstGeom prst="rect">
+            <a:avLst/>
+          </a:prstGeom>
+          <a:noFill/>
+          <a:ln/>
+        </p:spPr>
+        <p:txBody>
+          <a:bodyPr wrap="square" rtlCol="0" anchor="ctr"/>
+          <a:lstStyle/>
+          <a:p>
+            <a:pPr algn="ctr" indent="0" marL="0">
+              <a:buNone/>
+            </a:pPr>
+            <a:r>
+              <a:rPr lang="en-US" sz="1500" b="1" dirty="0">
+                <a:solidFill>
+                  <a:srgbClr val="1E2761"/>
+                </a:solidFill>
+                <a:latin typeface="Calibri" pitchFamily="34" charset="0"/>
+                <a:ea typeface="Calibri" pitchFamily="34" charset="-122"/>
+                <a:cs typeface="Calibri" pitchFamily="34" charset="-120"/>
+              </a:rPr>
+              <a:t>Q4</a:t>
+            </a:r>
+            <a:endParaRPr lang="en-US" sz="1500" dirty="0"/>
+          </a:p>
+        </p:txBody>
+      </p:sp>
+      <p:sp>
+        <p:nvSpPr>
+          <p:cNvPr id="19" name="Text 17"/>
+          <p:cNvSpPr/>
+          <p:nvPr/>
+        </p:nvSpPr>
+        <p:spPr>
+          <a:xfrm>
+            <a:off x="7132320" y="4096512"/>
+            <a:ext cx="4206240" cy="1417320"/>
+          </a:xfrm>
+          <a:prstGeom prst="rect">
+            <a:avLst/>
+          </a:prstGeom>
+          <a:noFill/>
+          <a:ln/>
+        </p:spPr>
+        <p:txBody>
+          <a:bodyPr wrap="square" rtlCol="0" anchor="ctr"/>
+          <a:lstStyle/>
+          <a:p>
+            <a:pPr indent="0" marL="0">
+              <a:lnSpc>
+                <a:spcPct val="110000"/>
+              </a:lnSpc>
+              <a:buNone/>
+            </a:pPr>
+            <a:r>
+              <a:rPr lang="en-US" sz="1500" dirty="0">
+                <a:solidFill>
+                  <a:srgbClr val="FFFFFF"/>
+                </a:solidFill>
+                <a:latin typeface="Calibri" pitchFamily="34" charset="0"/>
+                <a:ea typeface="Calibri" pitchFamily="34" charset="-122"/>
+                <a:cs typeface="Calibri" pitchFamily="34" charset="-120"/>
+              </a:rPr>
+              <a:t>Name one thing non-clinical staff MAY NOT do.</a:t>
+            </a:r>
+            <a:endParaRPr lang="en-US" sz="1500" dirty="0"/>
+          </a:p>
+        </p:txBody>
+      </p:sp>
+      <p:sp>
+        <p:nvSpPr>
+          <p:cNvPr id="20" name="Text 18"/>
+          <p:cNvSpPr/>
+          <p:nvPr/>
+        </p:nvSpPr>
+        <p:spPr>
+          <a:xfrm>
+            <a:off x="548640" y="6053328"/>
+            <a:ext cx="11064240" cy="320040"/>
+          </a:xfrm>
+          <a:prstGeom prst="rect">
+            <a:avLst/>
+          </a:prstGeom>
+          <a:noFill/>
+          <a:ln/>
+        </p:spPr>
+        <p:txBody>
+          <a:bodyPr wrap="square" rtlCol="0" anchor="ctr"/>
+          <a:lstStyle/>
+          <a:p>
+            <a:pPr indent="0" marL="0">
+              <a:buNone/>
+            </a:pPr>
+            <a:r>
+              <a:rPr lang="en-US" sz="1100" i="1" dirty="0">
+                <a:solidFill>
+                  <a:srgbClr val="CADCFC"/>
+                </a:solidFill>
+                <a:latin typeface="Calibri" pitchFamily="34" charset="0"/>
+                <a:ea typeface="Calibri" pitchFamily="34" charset="-122"/>
+                <a:cs typeface="Calibri" pitchFamily="34" charset="-120"/>
+              </a:rPr>
+              <a:t>Answers in the speaker notes · full written assessment administered separately</a:t>
+            </a:r>
+            <a:endParaRPr lang="en-US" sz="1100" dirty="0"/>
+          </a:p>
+        </p:txBody>
+      </p:sp>
+      <p:sp>
+        <p:nvSpPr>
+          <p:cNvPr id="21" name="Text 19"/>
+          <p:cNvSpPr/>
+          <p:nvPr/>
+        </p:nvSpPr>
+        <p:spPr>
+          <a:xfrm>
+            <a:off x="11551615" y="6446520"/>
+            <a:ext cx="365760" cy="274320"/>
+          </a:xfrm>
+          <a:prstGeom prst="rect">
+            <a:avLst/>
+          </a:prstGeom>
+          <a:noFill/>
+          <a:ln/>
+        </p:spPr>
+        <p:txBody>
+          <a:bodyPr wrap="square" rtlCol="0" anchor="ctr"/>
+          <a:lstStyle/>
+          <a:p>
+            <a:pPr algn="r" indent="0" marL="0">
+              <a:buNone/>
+            </a:pPr>
+            <a:r>
+              <a:rPr lang="en-US" sz="1000" dirty="0">
+                <a:solidFill>
+                  <a:srgbClr val="9AA3B2"/>
+                </a:solidFill>
+                <a:latin typeface="Calibri" pitchFamily="34" charset="0"/>
+                <a:ea typeface="Calibri" pitchFamily="34" charset="-122"/>
+                <a:cs typeface="Calibri" pitchFamily="34" charset="-120"/>
+              </a:rPr>
+              <a:t>20</a:t>
+            </a:r>
+            <a:endParaRPr lang="en-US" sz="1000" dirty="0"/>
+          </a:p>
+        </p:txBody>
+      </p:sp>
+      <p:sp>
+        <p:nvSpPr>
+          <p:cNvPr id="22" name="Text 20"/>
+          <p:cNvSpPr/>
+          <p:nvPr/>
+        </p:nvSpPr>
+        <p:spPr>
+          <a:xfrm>
+            <a:off x="457200" y="6446520"/>
+            <a:ext cx="5486400" cy="274320"/>
+          </a:xfrm>
+          <a:prstGeom prst="rect">
+            <a:avLst/>
+          </a:prstGeom>
+          <a:noFill/>
+          <a:ln/>
+        </p:spPr>
+        <p:txBody>
+          <a:bodyPr wrap="square" rtlCol="0" anchor="ctr"/>
+          <a:lstStyle/>
+          <a:p>
+            <a:pPr indent="0" marL="0">
+              <a:buNone/>
+            </a:pPr>
+            <a:r>
+              <a:rPr lang="en-US" sz="900" dirty="0">
+                <a:solidFill>
+                  <a:srgbClr val="AAB2C0"/>
+                </a:solidFill>
+                <a:latin typeface="Calibri" pitchFamily="34" charset="0"/>
+                <a:ea typeface="Calibri" pitchFamily="34" charset="-122"/>
+                <a:cs typeface="Calibri" pitchFamily="34" charset="-120"/>
+              </a:rPr>
+              <a:t>CharmEd Minds™ · Employee Training</a:t>
+            </a:r>
+            <a:endParaRPr lang="en-US" sz="900" dirty="0"/>
+          </a:p>
+        </p:txBody>
+      </p:sp>
+    </p:spTree>
+  </p:cSld>
+  <p:clrMapOvr>
+    <a:masterClrMapping/>
+  </p:clrMapOvr>
+</p:sld>
+</file>
+
+<file path=ppt/slides/slide21.xml><?xml version="1.0" encoding="utf-8"?>
+<p:sld xmlns:a="http://schemas.openxmlformats.org/drawingml/2006/main" xmlns:r="http://schemas.openxmlformats.org/officeDocument/2006/relationships" xmlns:p="http://schemas.openxmlformats.org/presentationml/2006/main">
+  <p:cSld name="Slide 21">
+    <p:bg>
+      <p:bgPr>
+        <a:solidFill>
+          <a:srgbClr val="FFFFFF"/>
+        </a:solidFill>
+      </p:bgPr>
+    </p:bg>
+    <p:spTree>
+      <p:nvGrpSpPr>
+        <p:cNvPr id="1" name=""/>
+        <p:cNvGrpSpPr/>
+        <p:nvPr/>
+      </p:nvGrpSpPr>
+      <p:grpSpPr>
+        <a:xfrm>
+          <a:off x="0" y="0"/>
+          <a:ext cx="0" cy="0"/>
+          <a:chOff x="0" y="0"/>
+          <a:chExt cx="0" cy="0"/>
+        </a:xfrm>
+      </p:grpSpPr>
+      <p:sp>
+        <p:nvSpPr>
+          <p:cNvPr id="2" name="Text 0"/>
+          <p:cNvSpPr/>
+          <p:nvPr/>
+        </p:nvSpPr>
+        <p:spPr>
+          <a:xfrm>
+            <a:off x="548640" y="411480"/>
+            <a:ext cx="10972800" cy="274320"/>
+          </a:xfrm>
+          <a:prstGeom prst="rect">
+            <a:avLst/>
+          </a:prstGeom>
+          <a:noFill/>
+          <a:ln/>
+        </p:spPr>
+        <p:txBody>
+          <a:bodyPr wrap="square" rtlCol="0" anchor="ctr"/>
+          <a:lstStyle/>
+          <a:p>
+            <a:pPr indent="0" marL="0">
+              <a:buNone/>
+            </a:pPr>
+            <a:r>
+              <a:rPr lang="en-US" sz="1200" b="1" spc="200" kern="0" dirty="0">
+                <a:solidFill>
+                  <a:srgbClr val="02C39A"/>
+                </a:solidFill>
+                <a:latin typeface="Calibri" pitchFamily="34" charset="0"/>
+                <a:ea typeface="Calibri" pitchFamily="34" charset="-122"/>
+                <a:cs typeface="Calibri" pitchFamily="34" charset="-120"/>
+              </a:rPr>
+              <a:t>KNOWLEDGE CHECK · ROUND 2</a:t>
+            </a:r>
+            <a:endParaRPr lang="en-US" sz="1200" dirty="0"/>
+          </a:p>
+        </p:txBody>
+      </p:sp>
+      <p:sp>
+        <p:nvSpPr>
+          <p:cNvPr id="3" name="Text 1"/>
+          <p:cNvSpPr/>
+          <p:nvPr/>
+        </p:nvSpPr>
+        <p:spPr>
+          <a:xfrm>
+            <a:off x="548640" y="658368"/>
+            <a:ext cx="11064240" cy="731520"/>
+          </a:xfrm>
+          <a:prstGeom prst="rect">
+            <a:avLst/>
+          </a:prstGeom>
+          <a:noFill/>
+          <a:ln/>
+        </p:spPr>
+        <p:txBody>
+          <a:bodyPr wrap="square" rtlCol="0" anchor="ctr"/>
+          <a:lstStyle/>
+          <a:p>
+            <a:pPr indent="0" marL="0">
+              <a:buNone/>
+            </a:pPr>
+            <a:r>
+              <a:rPr lang="en-US" sz="3000" b="1" dirty="0">
+                <a:solidFill>
+                  <a:srgbClr val="1E2761"/>
+                </a:solidFill>
+                <a:latin typeface="Cambria" pitchFamily="34" charset="0"/>
+                <a:ea typeface="Cambria" pitchFamily="34" charset="-122"/>
+                <a:cs typeface="Cambria" pitchFamily="34" charset="-120"/>
+              </a:rPr>
+              <a:t>Patient Journey &amp; Deadlines</a:t>
+            </a:r>
+            <a:endParaRPr lang="en-US" sz="3000" dirty="0"/>
+          </a:p>
+        </p:txBody>
+      </p:sp>
+      <p:sp>
+        <p:nvSpPr>
+          <p:cNvPr id="4" name="Shape 2"/>
+          <p:cNvSpPr/>
+          <p:nvPr/>
+        </p:nvSpPr>
+        <p:spPr>
+          <a:xfrm>
+            <a:off x="548640" y="1691640"/>
+            <a:ext cx="5440680" cy="1920240"/>
+          </a:xfrm>
+          <a:prstGeom prst="roundRect">
+            <a:avLst>
+              <a:gd name="adj" fmla="val 4762"/>
+            </a:avLst>
+          </a:prstGeom>
+          <a:solidFill>
+            <a:srgbClr val="F4F7FC"/>
+          </a:solidFill>
+          <a:ln w="12700">
+            <a:solidFill>
+              <a:srgbClr val="E2E9F3"/>
+            </a:solidFill>
+            <a:prstDash val="solid"/>
+          </a:ln>
+          <a:effectLst>
+            <a:outerShdw sx="100000" sy="100000" kx="0" ky="0" algn="bl" rotWithShape="0" blurRad="76200" dist="25400" dir="5400000">
+              <a:srgbClr val="BAC4D6">
+                <a:alpha val="35000"/>
+              </a:srgbClr>
+            </a:outerShdw>
+          </a:effectLst>
+        </p:spPr>
+      </p:sp>
+      <p:sp>
+        <p:nvSpPr>
+          <p:cNvPr id="5" name="Shape 3"/>
+          <p:cNvSpPr/>
+          <p:nvPr/>
+        </p:nvSpPr>
+        <p:spPr>
+          <a:xfrm>
+            <a:off x="804672" y="1947672"/>
+            <a:ext cx="548640" cy="548640"/>
+          </a:xfrm>
+          <a:prstGeom prst="ellipse">
+            <a:avLst/>
+          </a:prstGeom>
+          <a:solidFill>
+            <a:srgbClr val="02C39A"/>
+          </a:solidFill>
+          <a:ln/>
+        </p:spPr>
+      </p:sp>
+      <p:sp>
+        <p:nvSpPr>
+          <p:cNvPr id="6" name="Text 4"/>
+          <p:cNvSpPr/>
+          <p:nvPr/>
+        </p:nvSpPr>
+        <p:spPr>
+          <a:xfrm>
+            <a:off x="804672" y="1947672"/>
+            <a:ext cx="548640" cy="548640"/>
+          </a:xfrm>
+          <a:prstGeom prst="rect">
+            <a:avLst/>
+          </a:prstGeom>
+          <a:noFill/>
+          <a:ln/>
+        </p:spPr>
+        <p:txBody>
+          <a:bodyPr wrap="square" rtlCol="0" anchor="ctr"/>
+          <a:lstStyle/>
+          <a:p>
+            <a:pPr algn="ctr" indent="0" marL="0">
+              <a:buNone/>
+            </a:pPr>
+            <a:r>
+              <a:rPr lang="en-US" sz="1500" b="1" dirty="0">
+                <a:solidFill>
+                  <a:srgbClr val="FFFFFF"/>
+                </a:solidFill>
+                <a:latin typeface="Calibri" pitchFamily="34" charset="0"/>
+                <a:ea typeface="Calibri" pitchFamily="34" charset="-122"/>
+                <a:cs typeface="Calibri" pitchFamily="34" charset="-120"/>
+              </a:rPr>
+              <a:t>Q1</a:t>
+            </a:r>
+            <a:endParaRPr lang="en-US" sz="1500" dirty="0"/>
+          </a:p>
+        </p:txBody>
+      </p:sp>
+      <p:sp>
+        <p:nvSpPr>
+          <p:cNvPr id="7" name="Text 5"/>
+          <p:cNvSpPr/>
+          <p:nvPr/>
+        </p:nvSpPr>
+        <p:spPr>
+          <a:xfrm>
+            <a:off x="1508760" y="1947672"/>
+            <a:ext cx="4206240" cy="1417320"/>
+          </a:xfrm>
+          <a:prstGeom prst="rect">
+            <a:avLst/>
+          </a:prstGeom>
+          <a:noFill/>
+          <a:ln/>
+        </p:spPr>
+        <p:txBody>
+          <a:bodyPr wrap="square" rtlCol="0" anchor="ctr"/>
+          <a:lstStyle/>
+          <a:p>
+            <a:pPr indent="0" marL="0">
+              <a:lnSpc>
+                <a:spcPct val="110000"/>
+              </a:lnSpc>
+              <a:buNone/>
+            </a:pPr>
+            <a:r>
+              <a:rPr lang="en-US" sz="1500" dirty="0">
+                <a:solidFill>
+                  <a:srgbClr val="1E2761"/>
+                </a:solidFill>
+                <a:latin typeface="Calibri" pitchFamily="34" charset="0"/>
+                <a:ea typeface="Calibri" pitchFamily="34" charset="-122"/>
+                <a:cs typeface="Calibri" pitchFamily="34" charset="-120"/>
+              </a:rPr>
+              <a:t>What is the maximum time a referral may stay unassigned?</a:t>
+            </a:r>
+            <a:endParaRPr lang="en-US" sz="1500" dirty="0"/>
+          </a:p>
+        </p:txBody>
+      </p:sp>
+      <p:sp>
+        <p:nvSpPr>
+          <p:cNvPr id="8" name="Shape 6"/>
+          <p:cNvSpPr/>
+          <p:nvPr/>
+        </p:nvSpPr>
+        <p:spPr>
+          <a:xfrm>
+            <a:off x="6172200" y="1691640"/>
+            <a:ext cx="5440680" cy="1920240"/>
+          </a:xfrm>
+          <a:prstGeom prst="roundRect">
+            <a:avLst>
+              <a:gd name="adj" fmla="val 4762"/>
+            </a:avLst>
+          </a:prstGeom>
+          <a:solidFill>
+            <a:srgbClr val="F4F7FC"/>
+          </a:solidFill>
+          <a:ln w="12700">
+            <a:solidFill>
+              <a:srgbClr val="E2E9F3"/>
+            </a:solidFill>
+            <a:prstDash val="solid"/>
+          </a:ln>
+          <a:effectLst>
+            <a:outerShdw sx="100000" sy="100000" kx="0" ky="0" algn="bl" rotWithShape="0" blurRad="76200" dist="25400" dir="5400000">
+              <a:srgbClr val="BAC4D6">
+                <a:alpha val="35000"/>
+              </a:srgbClr>
+            </a:outerShdw>
+          </a:effectLst>
+        </p:spPr>
+      </p:sp>
+      <p:sp>
+        <p:nvSpPr>
+          <p:cNvPr id="9" name="Shape 7"/>
+          <p:cNvSpPr/>
+          <p:nvPr/>
+        </p:nvSpPr>
+        <p:spPr>
+          <a:xfrm>
+            <a:off x="6428232" y="1947672"/>
+            <a:ext cx="548640" cy="548640"/>
+          </a:xfrm>
+          <a:prstGeom prst="ellipse">
+            <a:avLst/>
+          </a:prstGeom>
+          <a:solidFill>
+            <a:srgbClr val="02C39A"/>
+          </a:solidFill>
+          <a:ln/>
+        </p:spPr>
+      </p:sp>
+      <p:sp>
+        <p:nvSpPr>
+          <p:cNvPr id="10" name="Text 8"/>
+          <p:cNvSpPr/>
+          <p:nvPr/>
+        </p:nvSpPr>
+        <p:spPr>
+          <a:xfrm>
+            <a:off x="6428232" y="1947672"/>
+            <a:ext cx="548640" cy="548640"/>
+          </a:xfrm>
+          <a:prstGeom prst="rect">
+            <a:avLst/>
+          </a:prstGeom>
+          <a:noFill/>
+          <a:ln/>
+        </p:spPr>
+        <p:txBody>
+          <a:bodyPr wrap="square" rtlCol="0" anchor="ctr"/>
+          <a:lstStyle/>
+          <a:p>
+            <a:pPr algn="ctr" indent="0" marL="0">
+              <a:buNone/>
+            </a:pPr>
+            <a:r>
+              <a:rPr lang="en-US" sz="1500" b="1" dirty="0">
+                <a:solidFill>
+                  <a:srgbClr val="FFFFFF"/>
+                </a:solidFill>
+                <a:latin typeface="Calibri" pitchFamily="34" charset="0"/>
+                <a:ea typeface="Calibri" pitchFamily="34" charset="-122"/>
+                <a:cs typeface="Calibri" pitchFamily="34" charset="-120"/>
+              </a:rPr>
+              <a:t>Q2</a:t>
+            </a:r>
+            <a:endParaRPr lang="en-US" sz="1500" dirty="0"/>
+          </a:p>
+        </p:txBody>
+      </p:sp>
+      <p:sp>
+        <p:nvSpPr>
+          <p:cNvPr id="11" name="Text 9"/>
+          <p:cNvSpPr/>
+          <p:nvPr/>
+        </p:nvSpPr>
+        <p:spPr>
+          <a:xfrm>
+            <a:off x="7132320" y="1947672"/>
+            <a:ext cx="4206240" cy="1417320"/>
+          </a:xfrm>
+          <a:prstGeom prst="rect">
+            <a:avLst/>
+          </a:prstGeom>
+          <a:noFill/>
+          <a:ln/>
+        </p:spPr>
+        <p:txBody>
+          <a:bodyPr wrap="square" rtlCol="0" anchor="ctr"/>
+          <a:lstStyle/>
+          <a:p>
+            <a:pPr indent="0" marL="0">
+              <a:lnSpc>
+                <a:spcPct val="110000"/>
+              </a:lnSpc>
+              <a:buNone/>
+            </a:pPr>
+            <a:r>
+              <a:rPr lang="en-US" sz="1500" dirty="0">
+                <a:solidFill>
+                  <a:srgbClr val="1E2761"/>
+                </a:solidFill>
+                <a:latin typeface="Calibri" pitchFamily="34" charset="0"/>
+                <a:ea typeface="Calibri" pitchFamily="34" charset="-122"/>
+                <a:cs typeface="Calibri" pitchFamily="34" charset="-120"/>
+              </a:rPr>
+              <a:t>The home digital testing must be completed within how long?</a:t>
+            </a:r>
+            <a:endParaRPr lang="en-US" sz="1500" dirty="0"/>
+          </a:p>
+        </p:txBody>
+      </p:sp>
+      <p:sp>
+        <p:nvSpPr>
+          <p:cNvPr id="12" name="Shape 10"/>
+          <p:cNvSpPr/>
+          <p:nvPr/>
+        </p:nvSpPr>
+        <p:spPr>
+          <a:xfrm>
+            <a:off x="548640" y="3840480"/>
+            <a:ext cx="5440680" cy="1920240"/>
+          </a:xfrm>
+          <a:prstGeom prst="roundRect">
+            <a:avLst>
+              <a:gd name="adj" fmla="val 4762"/>
+            </a:avLst>
+          </a:prstGeom>
+          <a:solidFill>
+            <a:srgbClr val="F4F7FC"/>
+          </a:solidFill>
+          <a:ln w="12700">
+            <a:solidFill>
+              <a:srgbClr val="E2E9F3"/>
+            </a:solidFill>
+            <a:prstDash val="solid"/>
+          </a:ln>
+          <a:effectLst>
+            <a:outerShdw sx="100000" sy="100000" kx="0" ky="0" algn="bl" rotWithShape="0" blurRad="76200" dist="25400" dir="5400000">
+              <a:srgbClr val="BAC4D6">
+                <a:alpha val="35000"/>
+              </a:srgbClr>
+            </a:outerShdw>
+          </a:effectLst>
+        </p:spPr>
+      </p:sp>
+      <p:sp>
+        <p:nvSpPr>
+          <p:cNvPr id="13" name="Shape 11"/>
+          <p:cNvSpPr/>
+          <p:nvPr/>
+        </p:nvSpPr>
+        <p:spPr>
+          <a:xfrm>
+            <a:off x="804672" y="4096512"/>
+            <a:ext cx="548640" cy="548640"/>
+          </a:xfrm>
+          <a:prstGeom prst="ellipse">
+            <a:avLst/>
+          </a:prstGeom>
+          <a:solidFill>
+            <a:srgbClr val="02C39A"/>
+          </a:solidFill>
+          <a:ln/>
+        </p:spPr>
+      </p:sp>
+      <p:sp>
+        <p:nvSpPr>
+          <p:cNvPr id="14" name="Text 12"/>
+          <p:cNvSpPr/>
+          <p:nvPr/>
+        </p:nvSpPr>
+        <p:spPr>
+          <a:xfrm>
+            <a:off x="804672" y="4096512"/>
+            <a:ext cx="548640" cy="548640"/>
+          </a:xfrm>
+          <a:prstGeom prst="rect">
+            <a:avLst/>
+          </a:prstGeom>
+          <a:noFill/>
+          <a:ln/>
+        </p:spPr>
+        <p:txBody>
+          <a:bodyPr wrap="square" rtlCol="0" anchor="ctr"/>
+          <a:lstStyle/>
+          <a:p>
+            <a:pPr algn="ctr" indent="0" marL="0">
+              <a:buNone/>
+            </a:pPr>
+            <a:r>
+              <a:rPr lang="en-US" sz="1500" b="1" dirty="0">
+                <a:solidFill>
+                  <a:srgbClr val="FFFFFF"/>
+                </a:solidFill>
+                <a:latin typeface="Calibri" pitchFamily="34" charset="0"/>
+                <a:ea typeface="Calibri" pitchFamily="34" charset="-122"/>
+                <a:cs typeface="Calibri" pitchFamily="34" charset="-120"/>
+              </a:rPr>
+              <a:t>Q3</a:t>
+            </a:r>
+            <a:endParaRPr lang="en-US" sz="1500" dirty="0"/>
+          </a:p>
+        </p:txBody>
+      </p:sp>
+      <p:sp>
+        <p:nvSpPr>
+          <p:cNvPr id="15" name="Text 13"/>
+          <p:cNvSpPr/>
+          <p:nvPr/>
+        </p:nvSpPr>
+        <p:spPr>
+          <a:xfrm>
+            <a:off x="1508760" y="4096512"/>
+            <a:ext cx="4206240" cy="1417320"/>
+          </a:xfrm>
+          <a:prstGeom prst="rect">
+            <a:avLst/>
+          </a:prstGeom>
+          <a:noFill/>
+          <a:ln/>
+        </p:spPr>
+        <p:txBody>
+          <a:bodyPr wrap="square" rtlCol="0" anchor="ctr"/>
+          <a:lstStyle/>
+          <a:p>
+            <a:pPr indent="0" marL="0">
+              <a:lnSpc>
+                <a:spcPct val="110000"/>
+              </a:lnSpc>
+              <a:buNone/>
+            </a:pPr>
+            <a:r>
+              <a:rPr lang="en-US" sz="1500" dirty="0">
+                <a:solidFill>
+                  <a:srgbClr val="1E2761"/>
+                </a:solidFill>
+                <a:latin typeface="Calibri" pitchFamily="34" charset="0"/>
+                <a:ea typeface="Calibri" pitchFamily="34" charset="-122"/>
+                <a:cs typeface="Calibri" pitchFamily="34" charset="-120"/>
+              </a:rPr>
+              <a:t>When must a weekly 97127 session be documented?</a:t>
+            </a:r>
+            <a:endParaRPr lang="en-US" sz="1500" dirty="0"/>
+          </a:p>
+        </p:txBody>
+      </p:sp>
+      <p:sp>
+        <p:nvSpPr>
+          <p:cNvPr id="16" name="Shape 14"/>
+          <p:cNvSpPr/>
+          <p:nvPr/>
+        </p:nvSpPr>
+        <p:spPr>
+          <a:xfrm>
+            <a:off x="6172200" y="3840480"/>
+            <a:ext cx="5440680" cy="1920240"/>
+          </a:xfrm>
+          <a:prstGeom prst="roundRect">
+            <a:avLst>
+              <a:gd name="adj" fmla="val 4762"/>
+            </a:avLst>
+          </a:prstGeom>
+          <a:solidFill>
+            <a:srgbClr val="F4F7FC"/>
+          </a:solidFill>
+          <a:ln w="12700">
+            <a:solidFill>
+              <a:srgbClr val="E2E9F3"/>
+            </a:solidFill>
+            <a:prstDash val="solid"/>
+          </a:ln>
+          <a:effectLst>
+            <a:outerShdw sx="100000" sy="100000" kx="0" ky="0" algn="bl" rotWithShape="0" blurRad="76200" dist="25400" dir="5400000">
+              <a:srgbClr val="BAC4D6">
+                <a:alpha val="35000"/>
+              </a:srgbClr>
+            </a:outerShdw>
+          </a:effectLst>
+        </p:spPr>
+      </p:sp>
+      <p:sp>
+        <p:nvSpPr>
+          <p:cNvPr id="17" name="Shape 15"/>
+          <p:cNvSpPr/>
+          <p:nvPr/>
+        </p:nvSpPr>
+        <p:spPr>
+          <a:xfrm>
+            <a:off x="6428232" y="4096512"/>
+            <a:ext cx="548640" cy="548640"/>
+          </a:xfrm>
+          <a:prstGeom prst="ellipse">
+            <a:avLst/>
+          </a:prstGeom>
+          <a:solidFill>
+            <a:srgbClr val="02C39A"/>
+          </a:solidFill>
+          <a:ln/>
+        </p:spPr>
+      </p:sp>
+      <p:sp>
+        <p:nvSpPr>
+          <p:cNvPr id="18" name="Text 16"/>
+          <p:cNvSpPr/>
+          <p:nvPr/>
+        </p:nvSpPr>
+        <p:spPr>
+          <a:xfrm>
+            <a:off x="6428232" y="4096512"/>
+            <a:ext cx="548640" cy="548640"/>
+          </a:xfrm>
+          <a:prstGeom prst="rect">
+            <a:avLst/>
+          </a:prstGeom>
+          <a:noFill/>
+          <a:ln/>
+        </p:spPr>
+        <p:txBody>
+          <a:bodyPr wrap="square" rtlCol="0" anchor="ctr"/>
+          <a:lstStyle/>
+          <a:p>
+            <a:pPr algn="ctr" indent="0" marL="0">
+              <a:buNone/>
+            </a:pPr>
+            <a:r>
+              <a:rPr lang="en-US" sz="1500" b="1" dirty="0">
+                <a:solidFill>
+                  <a:srgbClr val="FFFFFF"/>
+                </a:solidFill>
+                <a:latin typeface="Calibri" pitchFamily="34" charset="0"/>
+                <a:ea typeface="Calibri" pitchFamily="34" charset="-122"/>
+                <a:cs typeface="Calibri" pitchFamily="34" charset="-120"/>
+              </a:rPr>
+              <a:t>Q4</a:t>
+            </a:r>
+            <a:endParaRPr lang="en-US" sz="1500" dirty="0"/>
+          </a:p>
+        </p:txBody>
+      </p:sp>
+      <p:sp>
+        <p:nvSpPr>
+          <p:cNvPr id="19" name="Text 17"/>
+          <p:cNvSpPr/>
+          <p:nvPr/>
+        </p:nvSpPr>
+        <p:spPr>
+          <a:xfrm>
+            <a:off x="7132320" y="4096512"/>
+            <a:ext cx="4206240" cy="1417320"/>
+          </a:xfrm>
+          <a:prstGeom prst="rect">
+            <a:avLst/>
+          </a:prstGeom>
+          <a:noFill/>
+          <a:ln/>
+        </p:spPr>
+        <p:txBody>
+          <a:bodyPr wrap="square" rtlCol="0" anchor="ctr"/>
+          <a:lstStyle/>
+          <a:p>
+            <a:pPr indent="0" marL="0">
+              <a:lnSpc>
+                <a:spcPct val="110000"/>
+              </a:lnSpc>
+              <a:buNone/>
+            </a:pPr>
+            <a:r>
+              <a:rPr lang="en-US" sz="1500" dirty="0">
+                <a:solidFill>
+                  <a:srgbClr val="1E2761"/>
+                </a:solidFill>
+                <a:latin typeface="Calibri" pitchFamily="34" charset="0"/>
+                <a:ea typeface="Calibri" pitchFamily="34" charset="-122"/>
+                <a:cs typeface="Calibri" pitchFamily="34" charset="-120"/>
+              </a:rPr>
+              <a:t>At the monthly review, whose summary is read first — and by whom?</a:t>
+            </a:r>
+            <a:endParaRPr lang="en-US" sz="1500" dirty="0"/>
+          </a:p>
+        </p:txBody>
+      </p:sp>
+      <p:sp>
+        <p:nvSpPr>
+          <p:cNvPr id="20" name="Text 18"/>
+          <p:cNvSpPr/>
+          <p:nvPr/>
+        </p:nvSpPr>
+        <p:spPr>
+          <a:xfrm>
+            <a:off x="548640" y="6053328"/>
+            <a:ext cx="11064240" cy="320040"/>
+          </a:xfrm>
+          <a:prstGeom prst="rect">
+            <a:avLst/>
+          </a:prstGeom>
+          <a:noFill/>
+          <a:ln/>
+        </p:spPr>
+        <p:txBody>
+          <a:bodyPr wrap="square" rtlCol="0" anchor="ctr"/>
+          <a:lstStyle/>
+          <a:p>
+            <a:pPr indent="0" marL="0">
+              <a:buNone/>
+            </a:pPr>
+            <a:r>
+              <a:rPr lang="en-US" sz="1100" i="1" dirty="0">
+                <a:solidFill>
+                  <a:srgbClr val="4A4A55"/>
+                </a:solidFill>
+                <a:latin typeface="Calibri" pitchFamily="34" charset="0"/>
+                <a:ea typeface="Calibri" pitchFamily="34" charset="-122"/>
+                <a:cs typeface="Calibri" pitchFamily="34" charset="-120"/>
+              </a:rPr>
+              <a:t>Answers in the speaker notes · full written assessment administered separately</a:t>
+            </a:r>
+            <a:endParaRPr lang="en-US" sz="1100" dirty="0"/>
+          </a:p>
+        </p:txBody>
+      </p:sp>
+      <p:sp>
+        <p:nvSpPr>
+          <p:cNvPr id="21" name="Text 19"/>
+          <p:cNvSpPr/>
+          <p:nvPr/>
+        </p:nvSpPr>
+        <p:spPr>
+          <a:xfrm>
+            <a:off x="11551615" y="6446520"/>
+            <a:ext cx="365760" cy="274320"/>
+          </a:xfrm>
+          <a:prstGeom prst="rect">
+            <a:avLst/>
+          </a:prstGeom>
+          <a:noFill/>
+          <a:ln/>
+        </p:spPr>
+        <p:txBody>
+          <a:bodyPr wrap="square" rtlCol="0" anchor="ctr"/>
+          <a:lstStyle/>
+          <a:p>
+            <a:pPr algn="r" indent="0" marL="0">
+              <a:buNone/>
+            </a:pPr>
+            <a:r>
+              <a:rPr lang="en-US" sz="1000" dirty="0">
+                <a:solidFill>
+                  <a:srgbClr val="9AA3B2"/>
+                </a:solidFill>
+                <a:latin typeface="Calibri" pitchFamily="34" charset="0"/>
+                <a:ea typeface="Calibri" pitchFamily="34" charset="-122"/>
+                <a:cs typeface="Calibri" pitchFamily="34" charset="-120"/>
+              </a:rPr>
+              <a:t>21</a:t>
+            </a:r>
+            <a:endParaRPr lang="en-US" sz="1000" dirty="0"/>
+          </a:p>
+        </p:txBody>
+      </p:sp>
+      <p:sp>
+        <p:nvSpPr>
+          <p:cNvPr id="22" name="Text 20"/>
+          <p:cNvSpPr/>
+          <p:nvPr/>
+        </p:nvSpPr>
+        <p:spPr>
+          <a:xfrm>
+            <a:off x="457200" y="6446520"/>
+            <a:ext cx="5486400" cy="274320"/>
+          </a:xfrm>
+          <a:prstGeom prst="rect">
+            <a:avLst/>
+          </a:prstGeom>
+          <a:noFill/>
+          <a:ln/>
+        </p:spPr>
+        <p:txBody>
+          <a:bodyPr wrap="square" rtlCol="0" anchor="ctr"/>
+          <a:lstStyle/>
+          <a:p>
+            <a:pPr indent="0" marL="0">
+              <a:buNone/>
+            </a:pPr>
+            <a:r>
+              <a:rPr lang="en-US" sz="900" dirty="0">
+                <a:solidFill>
+                  <a:srgbClr val="AAB2C0"/>
+                </a:solidFill>
+                <a:latin typeface="Calibri" pitchFamily="34" charset="0"/>
+                <a:ea typeface="Calibri" pitchFamily="34" charset="-122"/>
+                <a:cs typeface="Calibri" pitchFamily="34" charset="-120"/>
+              </a:rPr>
+              <a:t>CharmEd Minds™ · Employee Training</a:t>
+            </a:r>
+            <a:endParaRPr lang="en-US" sz="900" dirty="0"/>
+          </a:p>
+        </p:txBody>
+      </p:sp>
+    </p:spTree>
+  </p:cSld>
+  <p:clrMapOvr>
+    <a:masterClrMapping/>
+  </p:clrMapOvr>
+</p:sld>
+</file>
+
+<file path=ppt/slides/slide22.xml><?xml version="1.0" encoding="utf-8"?>
+<p:sld xmlns:a="http://schemas.openxmlformats.org/drawingml/2006/main" xmlns:r="http://schemas.openxmlformats.org/officeDocument/2006/relationships" xmlns:p="http://schemas.openxmlformats.org/presentationml/2006/main">
+  <p:cSld name="Slide 22">
+    <p:bg>
+      <p:bgPr>
+        <a:solidFill>
+          <a:srgbClr val="FFFFFF"/>
+        </a:solidFill>
+      </p:bgPr>
+    </p:bg>
+    <p:spTree>
+      <p:nvGrpSpPr>
+        <p:cNvPr id="1" name=""/>
+        <p:cNvGrpSpPr/>
+        <p:nvPr/>
+      </p:nvGrpSpPr>
+      <p:grpSpPr>
+        <a:xfrm>
+          <a:off x="0" y="0"/>
+          <a:ext cx="0" cy="0"/>
+          <a:chOff x="0" y="0"/>
+          <a:chExt cx="0" cy="0"/>
+        </a:xfrm>
+      </p:grpSpPr>
+      <p:sp>
+        <p:nvSpPr>
+          <p:cNvPr id="2" name="Text 0"/>
+          <p:cNvSpPr/>
+          <p:nvPr/>
+        </p:nvSpPr>
+        <p:spPr>
+          <a:xfrm>
+            <a:off x="548640" y="411480"/>
+            <a:ext cx="10972800" cy="274320"/>
+          </a:xfrm>
+          <a:prstGeom prst="rect">
+            <a:avLst/>
+          </a:prstGeom>
+          <a:noFill/>
+          <a:ln/>
+        </p:spPr>
+        <p:txBody>
+          <a:bodyPr wrap="square" rtlCol="0" anchor="ctr"/>
+          <a:lstStyle/>
+          <a:p>
+            <a:pPr indent="0" marL="0">
+              <a:buNone/>
+            </a:pPr>
+            <a:r>
+              <a:rPr lang="en-US" sz="1200" b="1" spc="200" kern="0" dirty="0">
+                <a:solidFill>
+                  <a:srgbClr val="02C39A"/>
+                </a:solidFill>
+                <a:latin typeface="Calibri" pitchFamily="34" charset="0"/>
+                <a:ea typeface="Calibri" pitchFamily="34" charset="-122"/>
+                <a:cs typeface="Calibri" pitchFamily="34" charset="-120"/>
+              </a:rPr>
+              <a:t>KNOWLEDGE CHECK · ROUND 3</a:t>
+            </a:r>
+            <a:endParaRPr lang="en-US" sz="1200" dirty="0"/>
+          </a:p>
+        </p:txBody>
+      </p:sp>
+      <p:sp>
+        <p:nvSpPr>
+          <p:cNvPr id="3" name="Text 1"/>
+          <p:cNvSpPr/>
+          <p:nvPr/>
+        </p:nvSpPr>
+        <p:spPr>
+          <a:xfrm>
+            <a:off x="548640" y="658368"/>
+            <a:ext cx="11064240" cy="731520"/>
+          </a:xfrm>
+          <a:prstGeom prst="rect">
+            <a:avLst/>
+          </a:prstGeom>
+          <a:noFill/>
+          <a:ln/>
+        </p:spPr>
+        <p:txBody>
+          <a:bodyPr wrap="square" rtlCol="0" anchor="ctr"/>
+          <a:lstStyle/>
+          <a:p>
+            <a:pPr indent="0" marL="0">
+              <a:buNone/>
+            </a:pPr>
+            <a:r>
+              <a:rPr lang="en-US" sz="3000" b="1" dirty="0">
+                <a:solidFill>
+                  <a:srgbClr val="1E2761"/>
+                </a:solidFill>
+                <a:latin typeface="Cambria" pitchFamily="34" charset="0"/>
+                <a:ea typeface="Cambria" pitchFamily="34" charset="-122"/>
+                <a:cs typeface="Cambria" pitchFamily="34" charset="-120"/>
+              </a:rPr>
+              <a:t>Screening &amp; Documentation</a:t>
+            </a:r>
+            <a:endParaRPr lang="en-US" sz="3000" dirty="0"/>
+          </a:p>
+        </p:txBody>
+      </p:sp>
+      <p:sp>
+        <p:nvSpPr>
+          <p:cNvPr id="4" name="Shape 2"/>
+          <p:cNvSpPr/>
+          <p:nvPr/>
+        </p:nvSpPr>
+        <p:spPr>
+          <a:xfrm>
+            <a:off x="548640" y="1691640"/>
+            <a:ext cx="5440680" cy="1920240"/>
+          </a:xfrm>
+          <a:prstGeom prst="roundRect">
+            <a:avLst>
+              <a:gd name="adj" fmla="val 4762"/>
+            </a:avLst>
+          </a:prstGeom>
+          <a:solidFill>
+            <a:srgbClr val="F4F7FC"/>
+          </a:solidFill>
+          <a:ln w="12700">
+            <a:solidFill>
+              <a:srgbClr val="E2E9F3"/>
+            </a:solidFill>
+            <a:prstDash val="solid"/>
+          </a:ln>
+          <a:effectLst>
+            <a:outerShdw sx="100000" sy="100000" kx="0" ky="0" algn="bl" rotWithShape="0" blurRad="76200" dist="25400" dir="5400000">
+              <a:srgbClr val="BAC4D6">
+                <a:alpha val="35000"/>
+              </a:srgbClr>
+            </a:outerShdw>
+          </a:effectLst>
+        </p:spPr>
+      </p:sp>
+      <p:sp>
+        <p:nvSpPr>
+          <p:cNvPr id="5" name="Shape 3"/>
+          <p:cNvSpPr/>
+          <p:nvPr/>
+        </p:nvSpPr>
+        <p:spPr>
+          <a:xfrm>
+            <a:off x="804672" y="1947672"/>
+            <a:ext cx="548640" cy="548640"/>
+          </a:xfrm>
+          <a:prstGeom prst="ellipse">
+            <a:avLst/>
+          </a:prstGeom>
+          <a:solidFill>
+            <a:srgbClr val="02C39A"/>
+          </a:solidFill>
+          <a:ln/>
+        </p:spPr>
+      </p:sp>
+      <p:sp>
+        <p:nvSpPr>
+          <p:cNvPr id="6" name="Text 4"/>
+          <p:cNvSpPr/>
+          <p:nvPr/>
+        </p:nvSpPr>
+        <p:spPr>
+          <a:xfrm>
+            <a:off x="804672" y="1947672"/>
+            <a:ext cx="548640" cy="548640"/>
+          </a:xfrm>
+          <a:prstGeom prst="rect">
+            <a:avLst/>
+          </a:prstGeom>
+          <a:noFill/>
+          <a:ln/>
+        </p:spPr>
+        <p:txBody>
+          <a:bodyPr wrap="square" rtlCol="0" anchor="ctr"/>
+          <a:lstStyle/>
+          <a:p>
+            <a:pPr algn="ctr" indent="0" marL="0">
+              <a:buNone/>
+            </a:pPr>
+            <a:r>
+              <a:rPr lang="en-US" sz="1500" b="1" dirty="0">
+                <a:solidFill>
+                  <a:srgbClr val="FFFFFF"/>
+                </a:solidFill>
+                <a:latin typeface="Calibri" pitchFamily="34" charset="0"/>
+                <a:ea typeface="Calibri" pitchFamily="34" charset="-122"/>
+                <a:cs typeface="Calibri" pitchFamily="34" charset="-120"/>
+              </a:rPr>
+              <a:t>Q1</a:t>
+            </a:r>
+            <a:endParaRPr lang="en-US" sz="1500" dirty="0"/>
+          </a:p>
+        </p:txBody>
+      </p:sp>
+      <p:sp>
+        <p:nvSpPr>
+          <p:cNvPr id="7" name="Text 5"/>
+          <p:cNvSpPr/>
+          <p:nvPr/>
+        </p:nvSpPr>
+        <p:spPr>
+          <a:xfrm>
+            <a:off x="1508760" y="1947672"/>
+            <a:ext cx="4206240" cy="1417320"/>
+          </a:xfrm>
+          <a:prstGeom prst="rect">
+            <a:avLst/>
+          </a:prstGeom>
+          <a:noFill/>
+          <a:ln/>
+        </p:spPr>
+        <p:txBody>
+          <a:bodyPr wrap="square" rtlCol="0" anchor="ctr"/>
+          <a:lstStyle/>
+          <a:p>
+            <a:pPr indent="0" marL="0">
+              <a:lnSpc>
+                <a:spcPct val="110000"/>
+              </a:lnSpc>
+              <a:buNone/>
+            </a:pPr>
+            <a:r>
+              <a:rPr lang="en-US" sz="1500" dirty="0">
+                <a:solidFill>
+                  <a:srgbClr val="1E2761"/>
+                </a:solidFill>
+                <a:latin typeface="Calibri" pitchFamily="34" charset="0"/>
+                <a:ea typeface="Calibri" pitchFamily="34" charset="-122"/>
+                <a:cs typeface="Calibri" pitchFamily="34" charset="-120"/>
+              </a:rPr>
+              <a:t>Name the two primary computerized cognitive batteries.</a:t>
+            </a:r>
+            <a:endParaRPr lang="en-US" sz="1500" dirty="0"/>
+          </a:p>
+        </p:txBody>
+      </p:sp>
+      <p:sp>
+        <p:nvSpPr>
+          <p:cNvPr id="8" name="Shape 6"/>
+          <p:cNvSpPr/>
+          <p:nvPr/>
+        </p:nvSpPr>
+        <p:spPr>
+          <a:xfrm>
+            <a:off x="6172200" y="1691640"/>
+            <a:ext cx="5440680" cy="1920240"/>
+          </a:xfrm>
+          <a:prstGeom prst="roundRect">
+            <a:avLst>
+              <a:gd name="adj" fmla="val 4762"/>
+            </a:avLst>
+          </a:prstGeom>
+          <a:solidFill>
+            <a:srgbClr val="F4F7FC"/>
+          </a:solidFill>
+          <a:ln w="12700">
+            <a:solidFill>
+              <a:srgbClr val="E2E9F3"/>
+            </a:solidFill>
+            <a:prstDash val="solid"/>
+          </a:ln>
+          <a:effectLst>
+            <a:outerShdw sx="100000" sy="100000" kx="0" ky="0" algn="bl" rotWithShape="0" blurRad="76200" dist="25400" dir="5400000">
+              <a:srgbClr val="BAC4D6">
+                <a:alpha val="35000"/>
+              </a:srgbClr>
+            </a:outerShdw>
+          </a:effectLst>
+        </p:spPr>
+      </p:sp>
+      <p:sp>
+        <p:nvSpPr>
+          <p:cNvPr id="9" name="Shape 7"/>
+          <p:cNvSpPr/>
+          <p:nvPr/>
+        </p:nvSpPr>
+        <p:spPr>
+          <a:xfrm>
+            <a:off x="6428232" y="1947672"/>
+            <a:ext cx="548640" cy="548640"/>
+          </a:xfrm>
+          <a:prstGeom prst="ellipse">
+            <a:avLst/>
+          </a:prstGeom>
+          <a:solidFill>
+            <a:srgbClr val="02C39A"/>
+          </a:solidFill>
+          <a:ln/>
+        </p:spPr>
+      </p:sp>
+      <p:sp>
+        <p:nvSpPr>
+          <p:cNvPr id="10" name="Text 8"/>
+          <p:cNvSpPr/>
+          <p:nvPr/>
+        </p:nvSpPr>
+        <p:spPr>
+          <a:xfrm>
+            <a:off x="6428232" y="1947672"/>
+            <a:ext cx="548640" cy="548640"/>
+          </a:xfrm>
+          <a:prstGeom prst="rect">
+            <a:avLst/>
+          </a:prstGeom>
+          <a:noFill/>
+          <a:ln/>
+        </p:spPr>
+        <p:txBody>
+          <a:bodyPr wrap="square" rtlCol="0" anchor="ctr"/>
+          <a:lstStyle/>
+          <a:p>
+            <a:pPr algn="ctr" indent="0" marL="0">
+              <a:buNone/>
+            </a:pPr>
+            <a:r>
+              <a:rPr lang="en-US" sz="1500" b="1" dirty="0">
+                <a:solidFill>
+                  <a:srgbClr val="FFFFFF"/>
+                </a:solidFill>
+                <a:latin typeface="Calibri" pitchFamily="34" charset="0"/>
+                <a:ea typeface="Calibri" pitchFamily="34" charset="-122"/>
+                <a:cs typeface="Calibri" pitchFamily="34" charset="-120"/>
+              </a:rPr>
+              <a:t>Q2</a:t>
+            </a:r>
+            <a:endParaRPr lang="en-US" sz="1500" dirty="0"/>
+          </a:p>
+        </p:txBody>
+      </p:sp>
+      <p:sp>
+        <p:nvSpPr>
+          <p:cNvPr id="11" name="Text 9"/>
+          <p:cNvSpPr/>
+          <p:nvPr/>
+        </p:nvSpPr>
+        <p:spPr>
+          <a:xfrm>
+            <a:off x="7132320" y="1947672"/>
+            <a:ext cx="4206240" cy="1417320"/>
+          </a:xfrm>
+          <a:prstGeom prst="rect">
+            <a:avLst/>
+          </a:prstGeom>
+          <a:noFill/>
+          <a:ln/>
+        </p:spPr>
+        <p:txBody>
+          <a:bodyPr wrap="square" rtlCol="0" anchor="ctr"/>
+          <a:lstStyle/>
+          <a:p>
+            <a:pPr indent="0" marL="0">
+              <a:lnSpc>
+                <a:spcPct val="110000"/>
+              </a:lnSpc>
+              <a:buNone/>
+            </a:pPr>
+            <a:r>
+              <a:rPr lang="en-US" sz="1500" dirty="0">
+                <a:solidFill>
+                  <a:srgbClr val="1E2761"/>
+                </a:solidFill>
+                <a:latin typeface="Calibri" pitchFamily="34" charset="0"/>
+                <a:ea typeface="Calibri" pitchFamily="34" charset="-122"/>
+                <a:cs typeface="Calibri" pitchFamily="34" charset="-120"/>
+              </a:rPr>
+              <a:t>To clarify AuDHD, which four screening categories combine?</a:t>
+            </a:r>
+            <a:endParaRPr lang="en-US" sz="1500" dirty="0"/>
+          </a:p>
+        </p:txBody>
+      </p:sp>
+      <p:sp>
+        <p:nvSpPr>
+          <p:cNvPr id="12" name="Shape 10"/>
+          <p:cNvSpPr/>
+          <p:nvPr/>
+        </p:nvSpPr>
+        <p:spPr>
+          <a:xfrm>
+            <a:off x="548640" y="3840480"/>
+            <a:ext cx="5440680" cy="1920240"/>
+          </a:xfrm>
+          <a:prstGeom prst="roundRect">
+            <a:avLst>
+              <a:gd name="adj" fmla="val 4762"/>
+            </a:avLst>
+          </a:prstGeom>
+          <a:solidFill>
+            <a:srgbClr val="F4F7FC"/>
+          </a:solidFill>
+          <a:ln w="12700">
+            <a:solidFill>
+              <a:srgbClr val="E2E9F3"/>
+            </a:solidFill>
+            <a:prstDash val="solid"/>
+          </a:ln>
+          <a:effectLst>
+            <a:outerShdw sx="100000" sy="100000" kx="0" ky="0" algn="bl" rotWithShape="0" blurRad="76200" dist="25400" dir="5400000">
+              <a:srgbClr val="BAC4D6">
+                <a:alpha val="35000"/>
+              </a:srgbClr>
+            </a:outerShdw>
+          </a:effectLst>
+        </p:spPr>
+      </p:sp>
+      <p:sp>
+        <p:nvSpPr>
+          <p:cNvPr id="13" name="Shape 11"/>
+          <p:cNvSpPr/>
+          <p:nvPr/>
+        </p:nvSpPr>
+        <p:spPr>
+          <a:xfrm>
+            <a:off x="804672" y="4096512"/>
+            <a:ext cx="548640" cy="548640"/>
+          </a:xfrm>
+          <a:prstGeom prst="ellipse">
+            <a:avLst/>
+          </a:prstGeom>
+          <a:solidFill>
+            <a:srgbClr val="02C39A"/>
+          </a:solidFill>
+          <a:ln/>
+        </p:spPr>
+      </p:sp>
+      <p:sp>
+        <p:nvSpPr>
+          <p:cNvPr id="14" name="Text 12"/>
+          <p:cNvSpPr/>
+          <p:nvPr/>
+        </p:nvSpPr>
+        <p:spPr>
+          <a:xfrm>
+            <a:off x="804672" y="4096512"/>
+            <a:ext cx="548640" cy="548640"/>
+          </a:xfrm>
+          <a:prstGeom prst="rect">
+            <a:avLst/>
+          </a:prstGeom>
+          <a:noFill/>
+          <a:ln/>
+        </p:spPr>
+        <p:txBody>
+          <a:bodyPr wrap="square" rtlCol="0" anchor="ctr"/>
+          <a:lstStyle/>
+          <a:p>
+            <a:pPr algn="ctr" indent="0" marL="0">
+              <a:buNone/>
+            </a:pPr>
+            <a:r>
+              <a:rPr lang="en-US" sz="1500" b="1" dirty="0">
+                <a:solidFill>
+                  <a:srgbClr val="FFFFFF"/>
+                </a:solidFill>
+                <a:latin typeface="Calibri" pitchFamily="34" charset="0"/>
+                <a:ea typeface="Calibri" pitchFamily="34" charset="-122"/>
+                <a:cs typeface="Calibri" pitchFamily="34" charset="-120"/>
+              </a:rPr>
+              <a:t>Q3</a:t>
+            </a:r>
+            <a:endParaRPr lang="en-US" sz="1500" dirty="0"/>
+          </a:p>
+        </p:txBody>
+      </p:sp>
+      <p:sp>
+        <p:nvSpPr>
+          <p:cNvPr id="15" name="Text 13"/>
+          <p:cNvSpPr/>
+          <p:nvPr/>
+        </p:nvSpPr>
+        <p:spPr>
+          <a:xfrm>
+            <a:off x="1508760" y="4096512"/>
+            <a:ext cx="4206240" cy="1417320"/>
+          </a:xfrm>
+          <a:prstGeom prst="rect">
+            <a:avLst/>
+          </a:prstGeom>
+          <a:noFill/>
+          <a:ln/>
+        </p:spPr>
+        <p:txBody>
+          <a:bodyPr wrap="square" rtlCol="0" anchor="ctr"/>
+          <a:lstStyle/>
+          <a:p>
+            <a:pPr indent="0" marL="0">
+              <a:lnSpc>
+                <a:spcPct val="110000"/>
+              </a:lnSpc>
+              <a:buNone/>
+            </a:pPr>
+            <a:r>
+              <a:rPr lang="en-US" sz="1500" dirty="0">
+                <a:solidFill>
+                  <a:srgbClr val="1E2761"/>
+                </a:solidFill>
+                <a:latin typeface="Calibri" pitchFamily="34" charset="0"/>
+                <a:ea typeface="Calibri" pitchFamily="34" charset="-122"/>
+                <a:cs typeface="Calibri" pitchFamily="34" charset="-120"/>
+              </a:rPr>
+              <a:t>List the five required elements of a 97127 session note.</a:t>
+            </a:r>
+            <a:endParaRPr lang="en-US" sz="1500" dirty="0"/>
+          </a:p>
+        </p:txBody>
+      </p:sp>
+      <p:sp>
+        <p:nvSpPr>
+          <p:cNvPr id="16" name="Shape 14"/>
+          <p:cNvSpPr/>
+          <p:nvPr/>
+        </p:nvSpPr>
+        <p:spPr>
+          <a:xfrm>
+            <a:off x="6172200" y="3840480"/>
+            <a:ext cx="5440680" cy="1920240"/>
+          </a:xfrm>
+          <a:prstGeom prst="roundRect">
+            <a:avLst>
+              <a:gd name="adj" fmla="val 4762"/>
+            </a:avLst>
+          </a:prstGeom>
+          <a:solidFill>
+            <a:srgbClr val="F4F7FC"/>
+          </a:solidFill>
+          <a:ln w="12700">
+            <a:solidFill>
+              <a:srgbClr val="E2E9F3"/>
+            </a:solidFill>
+            <a:prstDash val="solid"/>
+          </a:ln>
+          <a:effectLst>
+            <a:outerShdw sx="100000" sy="100000" kx="0" ky="0" algn="bl" rotWithShape="0" blurRad="76200" dist="25400" dir="5400000">
+              <a:srgbClr val="BAC4D6">
+                <a:alpha val="35000"/>
+              </a:srgbClr>
+            </a:outerShdw>
+          </a:effectLst>
+        </p:spPr>
+      </p:sp>
+      <p:sp>
+        <p:nvSpPr>
+          <p:cNvPr id="17" name="Shape 15"/>
+          <p:cNvSpPr/>
+          <p:nvPr/>
+        </p:nvSpPr>
+        <p:spPr>
+          <a:xfrm>
+            <a:off x="6428232" y="4096512"/>
+            <a:ext cx="548640" cy="548640"/>
+          </a:xfrm>
+          <a:prstGeom prst="ellipse">
+            <a:avLst/>
+          </a:prstGeom>
+          <a:solidFill>
+            <a:srgbClr val="02C39A"/>
+          </a:solidFill>
+          <a:ln/>
+        </p:spPr>
+      </p:sp>
+      <p:sp>
+        <p:nvSpPr>
+          <p:cNvPr id="18" name="Text 16"/>
+          <p:cNvSpPr/>
+          <p:nvPr/>
+        </p:nvSpPr>
+        <p:spPr>
+          <a:xfrm>
+            <a:off x="6428232" y="4096512"/>
+            <a:ext cx="548640" cy="548640"/>
+          </a:xfrm>
+          <a:prstGeom prst="rect">
+            <a:avLst/>
+          </a:prstGeom>
+          <a:noFill/>
+          <a:ln/>
+        </p:spPr>
+        <p:txBody>
+          <a:bodyPr wrap="square" rtlCol="0" anchor="ctr"/>
+          <a:lstStyle/>
+          <a:p>
+            <a:pPr algn="ctr" indent="0" marL="0">
+              <a:buNone/>
+            </a:pPr>
+            <a:r>
+              <a:rPr lang="en-US" sz="1500" b="1" dirty="0">
+                <a:solidFill>
+                  <a:srgbClr val="FFFFFF"/>
+                </a:solidFill>
+                <a:latin typeface="Calibri" pitchFamily="34" charset="0"/>
+                <a:ea typeface="Calibri" pitchFamily="34" charset="-122"/>
+                <a:cs typeface="Calibri" pitchFamily="34" charset="-120"/>
+              </a:rPr>
+              <a:t>Q4</a:t>
+            </a:r>
+            <a:endParaRPr lang="en-US" sz="1500" dirty="0"/>
+          </a:p>
+        </p:txBody>
+      </p:sp>
+      <p:sp>
+        <p:nvSpPr>
+          <p:cNvPr id="19" name="Text 17"/>
+          <p:cNvSpPr/>
+          <p:nvPr/>
+        </p:nvSpPr>
+        <p:spPr>
+          <a:xfrm>
+            <a:off x="7132320" y="4096512"/>
+            <a:ext cx="4206240" cy="1417320"/>
+          </a:xfrm>
+          <a:prstGeom prst="rect">
+            <a:avLst/>
+          </a:prstGeom>
+          <a:noFill/>
+          <a:ln/>
+        </p:spPr>
+        <p:txBody>
+          <a:bodyPr wrap="square" rtlCol="0" anchor="ctr"/>
+          <a:lstStyle/>
+          <a:p>
+            <a:pPr indent="0" marL="0">
+              <a:lnSpc>
+                <a:spcPct val="110000"/>
+              </a:lnSpc>
+              <a:buNone/>
+            </a:pPr>
+            <a:r>
+              <a:rPr lang="en-US" sz="1500" dirty="0">
+                <a:solidFill>
+                  <a:srgbClr val="1E2761"/>
+                </a:solidFill>
+                <a:latin typeface="Calibri" pitchFamily="34" charset="0"/>
+                <a:ea typeface="Calibri" pitchFamily="34" charset="-122"/>
+                <a:cs typeface="Calibri" pitchFamily="34" charset="-120"/>
+              </a:rPr>
+              <a:t>Screening tools identify patterns — what do they NOT do?</a:t>
+            </a:r>
+            <a:endParaRPr lang="en-US" sz="1500" dirty="0"/>
+          </a:p>
+        </p:txBody>
+      </p:sp>
+      <p:sp>
+        <p:nvSpPr>
+          <p:cNvPr id="20" name="Text 18"/>
+          <p:cNvSpPr/>
+          <p:nvPr/>
+        </p:nvSpPr>
+        <p:spPr>
+          <a:xfrm>
+            <a:off x="548640" y="6053328"/>
+            <a:ext cx="11064240" cy="320040"/>
+          </a:xfrm>
+          <a:prstGeom prst="rect">
+            <a:avLst/>
+          </a:prstGeom>
+          <a:noFill/>
+          <a:ln/>
+        </p:spPr>
+        <p:txBody>
+          <a:bodyPr wrap="square" rtlCol="0" anchor="ctr"/>
+          <a:lstStyle/>
+          <a:p>
+            <a:pPr indent="0" marL="0">
+              <a:buNone/>
+            </a:pPr>
+            <a:r>
+              <a:rPr lang="en-US" sz="1100" i="1" dirty="0">
+                <a:solidFill>
+                  <a:srgbClr val="4A4A55"/>
+                </a:solidFill>
+                <a:latin typeface="Calibri" pitchFamily="34" charset="0"/>
+                <a:ea typeface="Calibri" pitchFamily="34" charset="-122"/>
+                <a:cs typeface="Calibri" pitchFamily="34" charset="-120"/>
+              </a:rPr>
+              <a:t>Answers in the speaker notes · full written assessment administered separately</a:t>
+            </a:r>
+            <a:endParaRPr lang="en-US" sz="1100" dirty="0"/>
+          </a:p>
+        </p:txBody>
+      </p:sp>
+      <p:sp>
+        <p:nvSpPr>
+          <p:cNvPr id="21" name="Text 19"/>
+          <p:cNvSpPr/>
+          <p:nvPr/>
+        </p:nvSpPr>
+        <p:spPr>
+          <a:xfrm>
+            <a:off x="11551615" y="6446520"/>
+            <a:ext cx="365760" cy="274320"/>
+          </a:xfrm>
+          <a:prstGeom prst="rect">
+            <a:avLst/>
+          </a:prstGeom>
+          <a:noFill/>
+          <a:ln/>
+        </p:spPr>
+        <p:txBody>
+          <a:bodyPr wrap="square" rtlCol="0" anchor="ctr"/>
+          <a:lstStyle/>
+          <a:p>
+            <a:pPr algn="r" indent="0" marL="0">
+              <a:buNone/>
+            </a:pPr>
+            <a:r>
+              <a:rPr lang="en-US" sz="1000" dirty="0">
+                <a:solidFill>
+                  <a:srgbClr val="9AA3B2"/>
+                </a:solidFill>
+                <a:latin typeface="Calibri" pitchFamily="34" charset="0"/>
+                <a:ea typeface="Calibri" pitchFamily="34" charset="-122"/>
+                <a:cs typeface="Calibri" pitchFamily="34" charset="-120"/>
+              </a:rPr>
+              <a:t>22</a:t>
+            </a:r>
+            <a:endParaRPr lang="en-US" sz="1000" dirty="0"/>
+          </a:p>
+        </p:txBody>
+      </p:sp>
+      <p:sp>
+        <p:nvSpPr>
+          <p:cNvPr id="22" name="Text 20"/>
+          <p:cNvSpPr/>
+          <p:nvPr/>
+        </p:nvSpPr>
+        <p:spPr>
+          <a:xfrm>
+            <a:off x="457200" y="6446520"/>
+            <a:ext cx="5486400" cy="274320"/>
+          </a:xfrm>
+          <a:prstGeom prst="rect">
+            <a:avLst/>
+          </a:prstGeom>
+          <a:noFill/>
+          <a:ln/>
+        </p:spPr>
+        <p:txBody>
+          <a:bodyPr wrap="square" rtlCol="0" anchor="ctr"/>
+          <a:lstStyle/>
+          <a:p>
+            <a:pPr indent="0" marL="0">
+              <a:buNone/>
+            </a:pPr>
+            <a:r>
+              <a:rPr lang="en-US" sz="900" dirty="0">
+                <a:solidFill>
+                  <a:srgbClr val="AAB2C0"/>
+                </a:solidFill>
+                <a:latin typeface="Calibri" pitchFamily="34" charset="0"/>
+                <a:ea typeface="Calibri" pitchFamily="34" charset="-122"/>
+                <a:cs typeface="Calibri" pitchFamily="34" charset="-120"/>
+              </a:rPr>
+              <a:t>CharmEd Minds™ · Employee Training</a:t>
+            </a:r>
+            <a:endParaRPr lang="en-US" sz="900" dirty="0"/>
+          </a:p>
+        </p:txBody>
+      </p:sp>
+    </p:spTree>
+  </p:cSld>
+  <p:clrMapOvr>
+    <a:masterClrMapping/>
+  </p:clrMapOvr>
+</p:sld>
+</file>
+
+<file path=ppt/slides/slide23.xml><?xml version="1.0" encoding="utf-8"?>
+<p:sld xmlns:a="http://schemas.openxmlformats.org/drawingml/2006/main" xmlns:r="http://schemas.openxmlformats.org/officeDocument/2006/relationships" xmlns:p="http://schemas.openxmlformats.org/presentationml/2006/main">
+  <p:cSld name="Slide 23">
+    <p:bg>
+      <p:bgPr>
+        <a:solidFill>
+          <a:srgbClr val="1E2761"/>
+        </a:solidFill>
+      </p:bgPr>
+    </p:bg>
+    <p:spTree>
+      <p:nvGrpSpPr>
+        <p:cNvPr id="1" name=""/>
+        <p:cNvGrpSpPr/>
+        <p:nvPr/>
+      </p:nvGrpSpPr>
+      <p:grpSpPr>
+        <a:xfrm>
+          <a:off x="0" y="0"/>
+          <a:ext cx="0" cy="0"/>
+          <a:chOff x="0" y="0"/>
+          <a:chExt cx="0" cy="0"/>
+        </a:xfrm>
+      </p:grpSpPr>
+      <p:sp>
+        <p:nvSpPr>
           <p:cNvPr id="2" name="Shape 0"/>
           <p:cNvSpPr/>
           <p:nvPr/>
@@ -14620,7 +17140,7 @@
                 <a:ea typeface="Calibri" pitchFamily="34" charset="-122"/>
                 <a:cs typeface="Calibri" pitchFamily="34" charset="-120"/>
               </a:rPr>
-              <a:t>Read the full Employee Training Guide · Complete your role competency checklist · Ask your APD</a:t>
+              <a:t>Read the full guide · Pass the competency assessment &amp; sign off · Complete your role checklist</a:t>
             </a:r>
             <a:endParaRPr lang="en-US" sz="1500" dirty="0"/>
           </a:p>
@@ -14720,7 +17240,7 @@
                 <a:ea typeface="Calibri" pitchFamily="34" charset="-122"/>
                 <a:cs typeface="Calibri" pitchFamily="34" charset="-120"/>
               </a:rPr>
-              <a:t>20</a:t>
+              <a:t>23</a:t>
             </a:r>
             <a:endParaRPr lang="en-US" sz="1000" dirty="0"/>
           </a:p>

</xml_diff>